<commit_message>
RB-11 deck da direção em Poppins (D55)
- scripts/deck/gerar_deck.js: fonte do tema passa a Poppins (Brand Guidelines para PowerPoint); textos encurtados onde a Poppins, mais larga, não cabia.
- D55 registada; CLAUDE.md, Q08, backlog e deliverables/README atualizados.

Co-Authored-By: Claude Opus 5.5 <noreply@anthropic.com>
Claude-Session: https://claude.ai/code/session_01YNUqftcRS5btUQxKvybzWR
</commit_message>
<xml_diff>
--- a/deliverables/arena-radar-direcao.pptx
+++ b/deliverables/arena-radar-direcao.pptx
@@ -115,35 +115,35 @@
   <p:extLst>
     <p:ext uri="{521415D9-36F7-43E2-AB2F-B90AF26B5E84}">
       <p14:sectionLst xmlns:p14="http://schemas.microsoft.com/office/powerpoint/2010/main">
-        <p14:section name="Abertura" id="{178a5604-a95e-b7f9-3594-5325ba5f29fd}">
+        <p14:section name="Abertura" id="{ab863d10-0bcf-967d-578e-627ee1d4678e}">
           <p14:sldIdLst>
             <p14:sldId id="256"/>
           </p14:sldIdLst>
         </p14:section>
-        <p14:section name="Contexto" id="{8006d65c-4596-dee2-de74-c1ccc083efb5}">
+        <p14:section name="Contexto" id="{564ac8e5-cfda-ebf1-d366-09f58dcf75ac}">
           <p14:sldIdLst>
             <p14:sldId id="257"/>
           </p14:sldIdLst>
         </p14:section>
-        <p14:section name="O produto" id="{f35f4c9c-8399-fcd9-9250-ea79ef5dbad1}">
+        <p14:section name="O produto" id="{01d77d9c-a080-607a-42b9-0bf65ec1e161}">
           <p14:sldIdLst>
             <p14:sldId id="258"/>
           </p14:sldIdLst>
         </p14:section>
-        <p14:section name="Demonstração" id="{e9275075-0715-fd11-1623-331209449175}">
+        <p14:section name="Demonstração" id="{692e892d-6fb3-ce30-bc56-22fb0ffbabcb}">
           <p14:sldIdLst>
             <p14:sldId id="259"/>
             <p14:sldId id="260"/>
             <p14:sldId id="261"/>
           </p14:sldIdLst>
         </p14:section>
-        <p14:section name="Estado e proposta" id="{045ce190-a05f-71b6-3e87-9755d2215933}">
+        <p14:section name="Estado e proposta" id="{223a1286-f16d-7680-2b6f-edf195137d2b}">
           <p14:sldIdLst>
             <p14:sldId id="262"/>
             <p14:sldId id="263"/>
           </p14:sldIdLst>
         </p14:section>
-        <p14:section name="Decisão" id="{e3a78fae-2071-4b10-7635-79d0c0c22928}">
+        <p14:section name="Decisão" id="{f13fc915-041e-042f-6f61-4a166532953a}">
           <p14:sldIdLst>
             <p14:sldId id="264"/>
           </p14:sldIdLst>
@@ -3357,7 +3357,7 @@
                   <a:srgbClr val="4E5F5C"/>
                 </a:solidFill>
               </a:rPr>
-              <a:t>Pontos de importância explicados, nunca uma caixa negra</a:t>
+              <a:t>Pontos explicados, nunca uma caixa negra</a:t>
             </a:r>
             <a:endParaRPr lang="en-US" sz="1300" dirty="0"/>
           </a:p>
@@ -5014,7 +5014,7 @@
                   <a:srgbClr val="4E5F5C"/>
                 </a:solidFill>
               </a:rPr>
-              <a:t>Demonstração com clientes e marcas fictícios (D33). Sem dados reais. Tracejado: o que se espera pelo histórico de cada marca. Última linha: o plano da Vetra.</a:t>
+              <a:t>Demonstração com clientes e marcas fictícios (D33). Sem dados reais. Tracejado: o esperado pelo histórico. Última linha: o plano da Vetra.</a:t>
             </a:r>
             <a:endParaRPr lang="en-US" sz="1100" dirty="0"/>
           </a:p>
@@ -5113,7 +5113,7 @@
                   <a:srgbClr val="4E5F5C"/>
                 </a:solidFill>
               </a:rPr>
-              <a:t>A Zefira começou a testar criativos com pouco alcance. No histórico, isso antecede a campanha de inverno em 2 semanas. A equipa prepara a resposta antes.</a:t>
+              <a:t>A Zefira começou a testar criativos com pouco alcance. No histórico, isso antecede a campanha de inverno: a equipa prepara a resposta antes.</a:t>
             </a:r>
             <a:endParaRPr lang="en-US" sz="1400" dirty="0"/>
           </a:p>
@@ -5408,7 +5408,7 @@
         <p:spPr>
           <a:xfrm>
             <a:off x="548640" y="5971032"/>
-            <a:ext cx="4762592" cy="274320"/>
+            <a:ext cx="11094415" cy="274320"/>
           </a:xfrm>
           <a:prstGeom prst="rect">
             <a:avLst/>
@@ -6169,7 +6169,7 @@
                             <a:srgbClr val="0F2623"/>
                           </a:solidFill>
                         </a:rPr>
-                        <a:t>Conceito e estrutura (radar de movimentos)</a:t>
+                        <a:t>Conceito e estrutura</a:t>
                       </a:r>
                       <a:endParaRPr lang="en-US" sz="1400" dirty="0"/>
                     </a:p>
@@ -6527,7 +6527,7 @@
                             <a:srgbClr val="0F2623"/>
                           </a:solidFill>
                         </a:rPr>
-                        <a:t>Deteção, importância, previsões e choques</a:t>
+                        <a:t>Deteção, previsões e choques</a:t>
                       </a:r>
                       <a:endParaRPr lang="en-US" sz="1400" dirty="0"/>
                     </a:p>
@@ -6706,7 +6706,7 @@
                             <a:srgbClr val="0F2623"/>
                           </a:solidFill>
                         </a:rPr>
-                        <a:t>Resumo e classificação de criativos por IA</a:t>
+                        <a:t>Resumo e classificação por IA</a:t>
                       </a:r>
                       <a:endParaRPr lang="en-US" sz="1400" dirty="0"/>
                     </a:p>
@@ -7064,7 +7064,7 @@
                             <a:srgbClr val="0F2623"/>
                           </a:solidFill>
                         </a:rPr>
-                        <a:t>Dados do cliente (pesquisa paga, plano de meios)</a:t>
+                        <a:t>Dados do cliente (pesquisa, plano)</a:t>
                       </a:r>
                       <a:endParaRPr lang="en-US" sz="1400" dirty="0"/>
                     </a:p>
@@ -7243,7 +7243,7 @@
                             <a:srgbClr val="0F2623"/>
                           </a:solidFill>
                         </a:rPr>
-                        <a:t>Partilha entre a equipa e stack de produção</a:t>
+                        <a:t>Partilha na equipa e stack</a:t>
                       </a:r>
                       <a:endParaRPr lang="en-US" sz="1400" dirty="0"/>
                     </a:p>
@@ -9230,7 +9230,7 @@
     </a:clrScheme>
     <a:fontScheme name="Arena Radar">
       <a:majorFont>
-        <a:latin typeface="Inter"/>
+        <a:latin typeface="Poppins"/>
         <a:ea typeface=""/>
         <a:cs typeface=""/>
         <a:font script="Jpan" typeface="游ゴシック Light"/>
@@ -9282,7 +9282,7 @@
         <a:font script="Tfng" typeface="Ebrima"/>
       </a:majorFont>
       <a:minorFont>
-        <a:latin typeface="Inter"/>
+        <a:latin typeface="Poppins"/>
         <a:ea typeface=""/>
         <a:cs typeface=""/>
         <a:font script="Jpan" typeface="游ゴシック"/>

</xml_diff>

<commit_message>
RB-120 deck explicativo «O que é o Arena Radar» (17 slides)
- scripts/deck/gerar_explicador.js: o que é, porque existe, o movimento, cinco áreas com capturas, antecipação, plano do cliente, respostas, resumo e IA, fontes, regras e estado; notas do orador em todos os slides.
- scripts/deck/comum.js: tema, layouts e auxiliares partilhados pelos dois decks (o deck da direção passa a usá-lo, sem mudanças no conteúdo).
- Capturas novas: ficha de concorrente, mapa de mensagens e resposta combinada.

Co-Authored-By: Claude Opus 5.5 <noreply@anthropic.com>
Claude-Session: https://claude.ai/code/session_01YNUqftcRS5btUQxKvybzWR
</commit_message>
<xml_diff>
--- a/deliverables/arena-radar-direcao.pptx
+++ b/deliverables/arena-radar-direcao.pptx
@@ -115,35 +115,35 @@
   <p:extLst>
     <p:ext uri="{521415D9-36F7-43E2-AB2F-B90AF26B5E84}">
       <p14:sectionLst xmlns:p14="http://schemas.microsoft.com/office/powerpoint/2010/main">
-        <p14:section name="Abertura" id="{ab863d10-0bcf-967d-578e-627ee1d4678e}">
+        <p14:section name="Abertura" id="{18cf7dbc-1968-5722-ad11-6d64d3d874b7}">
           <p14:sldIdLst>
             <p14:sldId id="256"/>
           </p14:sldIdLst>
         </p14:section>
-        <p14:section name="Contexto" id="{564ac8e5-cfda-ebf1-d366-09f58dcf75ac}">
+        <p14:section name="Contexto" id="{f78e9975-3871-44e1-53d7-9ddf118f5f96}">
           <p14:sldIdLst>
             <p14:sldId id="257"/>
           </p14:sldIdLst>
         </p14:section>
-        <p14:section name="O produto" id="{01d77d9c-a080-607a-42b9-0bf65ec1e161}">
+        <p14:section name="O produto" id="{895f18ff-0b60-9d7e-5103-81087c04e6d9}">
           <p14:sldIdLst>
             <p14:sldId id="258"/>
           </p14:sldIdLst>
         </p14:section>
-        <p14:section name="Demonstração" id="{692e892d-6fb3-ce30-bc56-22fb0ffbabcb}">
+        <p14:section name="Demonstração" id="{31d03925-06a8-3ee9-b597-465e29a8f026}">
           <p14:sldIdLst>
             <p14:sldId id="259"/>
             <p14:sldId id="260"/>
             <p14:sldId id="261"/>
           </p14:sldIdLst>
         </p14:section>
-        <p14:section name="Estado e proposta" id="{223a1286-f16d-7680-2b6f-edf195137d2b}">
+        <p14:section name="Estado e proposta" id="{c588a9fe-1c3b-b508-f57f-3bad34120b5c}">
           <p14:sldIdLst>
             <p14:sldId id="262"/>
             <p14:sldId id="263"/>
           </p14:sldIdLst>
         </p14:section>
-        <p14:section name="Decisão" id="{f13fc915-041e-042f-6f61-4a166532953a}">
+        <p14:section name="Decisão" id="{e5d28f5f-3707-c254-1e6e-820dfe30219a}">
           <p14:sldIdLst>
             <p14:sldId id="264"/>
           </p14:sldIdLst>

</xml_diff>